<commit_message>
fix: match HW2 slide examples to the handout and link the HW1 handout
Slide 6 now shows three examples copied from the HW2 handout
(1 8 -1, 1 4 1, and 8 10 0) instead of an invented 179 8 2 case,
and the caption notes the 8-bit output grouping. Slide 3 links the
HW1 handout on firner.com. The downloadable pptx is patched to match.
</commit_message>
<xml_diff>
--- a/public/presentations/cs211-recitation-01.pptx
+++ b/public/presentations/cs211-recitation-01.pptx
@@ -1132,7 +1132,7 @@
               <a:buNone/>
             </a:pPr>
             <a:r>
-              <a:t>Due date supplied by the TA. September is inferred from the recitation context. Do not announce a specific deadline time or late policy without checking Canvas.</a:t>
+              <a:t>Due date supplied by the TA. September is inferred from the recitation context. Do not announce a specific deadline time or late policy without checking Canvas. HW1 handout: https://firner.com/presentations/cs211/2026-Fall/hw1.html .</a:t>
             </a:r>
             <a:endParaRPr/>
           </a:p>
@@ -1372,7 +1372,7 @@
               <a:buNone/>
             </a:pPr>
             <a:r>
-              <a:t>Source: https://firner.com/presentations/cs211/2026-Fall/hw2.html . The handout specifies three arguments: value, selected width, and rotation count. Store the value in 64 bits using long long int and parse it with atoll. Positive rotation counts mean right, negative mean left. The handout says positive input values will be tested; the supplied script also tests zero. Print in eight-bit groups starting at the most significant displayed bit. Return 0 on success and 1 without output for an incorrect number of inputs. 8-bit examples are directly supported by the handout. 179 = 128 + 32 + 16 + 2 + 1.</a:t>
+              <a:t>Source: https://firner.com/presentations/cs211/2026-Fall/hw2.html . The handout specifies three arguments: value, selected width, and rotation count. Store the value in 64 bits using long long int and parse it with atoll. Positive rotation counts mean right, negative mean left. The handout says positive input values will be tested; the supplied script also tests zero. Print in eight-bit groups starting at the most significant displayed bit. Return 0 on success and 1 without output for an incorrect number of inputs. All three commands and outputs are copied from the handout’s example list: 1 8 -1 is a left rotation, 1 4 1 is a right rotation within a 4-bit width, and 8 10 0 shows that grouping starts at the top bit, so 00000010 00 is correct and 00 00001000 fails the test script.</a:t>
             </a:r>
             <a:endParaRPr/>
           </a:p>
@@ -13098,6 +13098,58 @@
           </a:p>
         </p:txBody>
       </p:sp>
+      <p:sp>
+        <p:nvSpPr>
+          <p:cNvPr id="535" name="Source link">
+            <a:extLst xmlns:a="http://schemas.openxmlformats.org/drawingml/2006/main">
+              <a:ext uri="{FF2B5EF4-FFF2-40B4-BE49-F238E27FC236}">
+                <a16:creationId xmlns:a16="http://schemas.microsoft.com/office/drawing/2014/main" id="{CBECD493-C2EB-48D2-850C-9B9F5DACFA30}"/>
+              </a:ext>
+            </a:extLst>
+          </p:cNvPr>
+          <p:cNvSpPr>
+            <a:spLocks xmlns:a="http://schemas.openxmlformats.org/drawingml/2006/main" noGrp="1"/>
+          </p:cNvSpPr>
+          <p:nvPr/>
+        </p:nvSpPr>
+        <p:spPr>
+          <a:xfrm xmlns:a="http://schemas.openxmlformats.org/drawingml/2006/main">
+            <a:off x="6257925" y="5238750"/>
+            <a:ext cx="5534025" cy="323850"/>
+          </a:xfrm>
+          <a:prstGeom xmlns:a="http://schemas.openxmlformats.org/drawingml/2006/main" prst="rect">
+            <a:avLst/>
+          </a:prstGeom>
+          <a:noFill xmlns:a="http://schemas.openxmlformats.org/drawingml/2006/main"/>
+          <a:ln xmlns:a="http://schemas.openxmlformats.org/drawingml/2006/main" w="0">
+            <a:noFill/>
+          </a:ln>
+        </p:spPr>
+        <p:txBody>
+          <a:bodyPr xmlns:a="http://schemas.openxmlformats.org/drawingml/2006/main" lIns="0" tIns="0" rIns="0" bIns="0" anchor="t">
+            <a:noAutofit/>
+          </a:bodyPr>
+          <a:lstStyle xmlns:a="http://schemas.openxmlformats.org/drawingml/2006/main"/>
+          <a:p xmlns:a="http://schemas.openxmlformats.org/drawingml/2006/main">
+            <a:pPr marL="0" indent="0">
+              <a:defRPr sz="1500">
+                <a:solidFill>
+                  <a:srgbClr val="CCCCCC"/>
+                </a:solidFill>
+                <a:latin typeface="Arial"/>
+                <a:ea typeface="Arial"/>
+                <a:cs typeface="Arial"/>
+              </a:defRPr>
+            </a:pPr>
+            <a:r>
+              <a:rPr>
+                <a:hlinkClick xmlns:r="http://schemas.openxmlformats.org/officeDocument/2006/relationships" r:id="Rhw1link00000001"/>
+              </a:rPr>
+              <a:t>HW1 assignment handout</a:t>
+            </a:r>
+          </a:p>
+        </p:txBody>
+      </p:sp>
     </p:spTree>
     <p:extLst>
       <p:ext uri="{BB962C8B-B14F-4D97-AF65-F5344CB8AC3E}">
@@ -15856,24 +15908,7 @@
                 <a:ea typeface="Consolas"/>
                 <a:cs typeface="Consolas"/>
               </a:rPr>
-              <a:t>./hw2 179 8 2</a:t>
-            </a:r>
-          </a:p>
-          <a:p xmlns:a="http://schemas.openxmlformats.org/drawingml/2006/main">
-            <a:pPr marL="0" indent="0">
-              <a:lnSpc>
-                <a:spcPct val="114000"/>
-              </a:lnSpc>
-              <a:spcBef>
-                <a:spcPts val="0"/>
-              </a:spcBef>
-              <a:spcAft>
-                <a:spcPts val="0"/>
-              </a:spcAft>
-              <a:buNone/>
-            </a:pPr>
-            <a:r>
-              <a:t/>
+              <a:t>./hw2 1 8 -1</a:t>
             </a:r>
           </a:p>
           <a:p xmlns:a="http://schemas.openxmlformats.org/drawingml/2006/main">
@@ -15906,7 +15941,7 @@
                 <a:ea typeface="Consolas"/>
                 <a:cs typeface="Consolas"/>
               </a:rPr>
-              <a:t>Start:   10110011</a:t>
+              <a:t>Start:   00000001</a:t>
             </a:r>
           </a:p>
           <a:p xmlns:a="http://schemas.openxmlformats.org/drawingml/2006/main">
@@ -15939,7 +15974,239 @@
                 <a:ea typeface="Consolas"/>
                 <a:cs typeface="Consolas"/>
               </a:rPr>
-              <a:t>Result:  11101100</a:t>
+              <a:t>Result:  00000010</a:t>
+            </a:r>
+          </a:p>
+          <a:p xmlns:a="http://schemas.openxmlformats.org/drawingml/2006/main">
+            <a:pPr marL="0" indent="0">
+              <a:lnSpc>
+                <a:spcPct val="114000"/>
+              </a:lnSpc>
+              <a:spcBef>
+                <a:spcPts val="0"/>
+              </a:spcBef>
+              <a:spcAft>
+                <a:spcPts val="0"/>
+              </a:spcAft>
+              <a:buNone/>
+            </a:pPr>
+            <a:r>
+              <a:t/>
+            </a:r>
+          </a:p>
+          <a:p xmlns:a="http://schemas.openxmlformats.org/drawingml/2006/main">
+            <a:pPr marL="0" indent="0">
+              <a:lnSpc>
+                <a:spcPct val="114000"/>
+              </a:lnSpc>
+              <a:spcBef>
+                <a:spcPts val="0"/>
+              </a:spcBef>
+              <a:spcAft>
+                <a:spcPts val="0"/>
+              </a:spcAft>
+              <a:buNone/>
+              <a:defRPr sz="1875">
+                <a:solidFill>
+                  <a:srgbClr val="FFFFFF"/>
+                </a:solidFill>
+                <a:latin typeface="Consolas"/>
+                <a:ea typeface="Consolas"/>
+                <a:cs typeface="Consolas"/>
+              </a:defRPr>
+            </a:pPr>
+            <a:r>
+              <a:rPr sz="1875">
+                <a:solidFill>
+                  <a:srgbClr val="FFFFFF"/>
+                </a:solidFill>
+                <a:latin typeface="Consolas"/>
+                <a:ea typeface="Consolas"/>
+                <a:cs typeface="Consolas"/>
+              </a:rPr>
+              <a:t>./hw2 1 4 1</a:t>
+            </a:r>
+          </a:p>
+          <a:p xmlns:a="http://schemas.openxmlformats.org/drawingml/2006/main">
+            <a:pPr marL="0" indent="0">
+              <a:lnSpc>
+                <a:spcPct val="114000"/>
+              </a:lnSpc>
+              <a:spcBef>
+                <a:spcPts val="0"/>
+              </a:spcBef>
+              <a:spcAft>
+                <a:spcPts val="0"/>
+              </a:spcAft>
+              <a:buNone/>
+              <a:defRPr sz="1875">
+                <a:solidFill>
+                  <a:srgbClr val="FFFFFF"/>
+                </a:solidFill>
+                <a:latin typeface="Consolas"/>
+                <a:ea typeface="Consolas"/>
+                <a:cs typeface="Consolas"/>
+              </a:defRPr>
+            </a:pPr>
+            <a:r>
+              <a:rPr sz="1875">
+                <a:solidFill>
+                  <a:srgbClr val="FFFFFF"/>
+                </a:solidFill>
+                <a:latin typeface="Consolas"/>
+                <a:ea typeface="Consolas"/>
+                <a:cs typeface="Consolas"/>
+              </a:rPr>
+              <a:t>Start:   0001</a:t>
+            </a:r>
+          </a:p>
+          <a:p xmlns:a="http://schemas.openxmlformats.org/drawingml/2006/main">
+            <a:pPr marL="0" indent="0">
+              <a:lnSpc>
+                <a:spcPct val="114000"/>
+              </a:lnSpc>
+              <a:spcBef>
+                <a:spcPts val="0"/>
+              </a:spcBef>
+              <a:spcAft>
+                <a:spcPts val="0"/>
+              </a:spcAft>
+              <a:buNone/>
+              <a:defRPr sz="1875">
+                <a:solidFill>
+                  <a:srgbClr val="FFFFFF"/>
+                </a:solidFill>
+                <a:latin typeface="Consolas"/>
+                <a:ea typeface="Consolas"/>
+                <a:cs typeface="Consolas"/>
+              </a:defRPr>
+            </a:pPr>
+            <a:r>
+              <a:rPr sz="1875">
+                <a:solidFill>
+                  <a:srgbClr val="FFFFFF"/>
+                </a:solidFill>
+                <a:latin typeface="Consolas"/>
+                <a:ea typeface="Consolas"/>
+                <a:cs typeface="Consolas"/>
+              </a:rPr>
+              <a:t>Result:  1000</a:t>
+            </a:r>
+          </a:p>
+          <a:p xmlns:a="http://schemas.openxmlformats.org/drawingml/2006/main">
+            <a:pPr marL="0" indent="0">
+              <a:lnSpc>
+                <a:spcPct val="114000"/>
+              </a:lnSpc>
+              <a:spcBef>
+                <a:spcPts val="0"/>
+              </a:spcBef>
+              <a:spcAft>
+                <a:spcPts val="0"/>
+              </a:spcAft>
+              <a:buNone/>
+            </a:pPr>
+            <a:r>
+              <a:t/>
+            </a:r>
+          </a:p>
+          <a:p xmlns:a="http://schemas.openxmlformats.org/drawingml/2006/main">
+            <a:pPr marL="0" indent="0">
+              <a:lnSpc>
+                <a:spcPct val="114000"/>
+              </a:lnSpc>
+              <a:spcBef>
+                <a:spcPts val="0"/>
+              </a:spcBef>
+              <a:spcAft>
+                <a:spcPts val="0"/>
+              </a:spcAft>
+              <a:buNone/>
+              <a:defRPr sz="1875">
+                <a:solidFill>
+                  <a:srgbClr val="FFFFFF"/>
+                </a:solidFill>
+                <a:latin typeface="Consolas"/>
+                <a:ea typeface="Consolas"/>
+                <a:cs typeface="Consolas"/>
+              </a:defRPr>
+            </a:pPr>
+            <a:r>
+              <a:rPr sz="1875">
+                <a:solidFill>
+                  <a:srgbClr val="FFFFFF"/>
+                </a:solidFill>
+                <a:latin typeface="Consolas"/>
+                <a:ea typeface="Consolas"/>
+                <a:cs typeface="Consolas"/>
+              </a:rPr>
+              <a:t>./hw2 8 10 0</a:t>
+            </a:r>
+          </a:p>
+          <a:p xmlns:a="http://schemas.openxmlformats.org/drawingml/2006/main">
+            <a:pPr marL="0" indent="0">
+              <a:lnSpc>
+                <a:spcPct val="114000"/>
+              </a:lnSpc>
+              <a:spcBef>
+                <a:spcPts val="0"/>
+              </a:spcBef>
+              <a:spcAft>
+                <a:spcPts val="0"/>
+              </a:spcAft>
+              <a:buNone/>
+              <a:defRPr sz="1875">
+                <a:solidFill>
+                  <a:srgbClr val="FFFFFF"/>
+                </a:solidFill>
+                <a:latin typeface="Consolas"/>
+                <a:ea typeface="Consolas"/>
+                <a:cs typeface="Consolas"/>
+              </a:defRPr>
+            </a:pPr>
+            <a:r>
+              <a:rPr sz="1875">
+                <a:solidFill>
+                  <a:srgbClr val="FFFFFF"/>
+                </a:solidFill>
+                <a:latin typeface="Consolas"/>
+                <a:ea typeface="Consolas"/>
+                <a:cs typeface="Consolas"/>
+              </a:rPr>
+              <a:t>Start:   00000010 00</a:t>
+            </a:r>
+          </a:p>
+          <a:p xmlns:a="http://schemas.openxmlformats.org/drawingml/2006/main">
+            <a:pPr marL="0" indent="0">
+              <a:lnSpc>
+                <a:spcPct val="114000"/>
+              </a:lnSpc>
+              <a:spcBef>
+                <a:spcPts val="0"/>
+              </a:spcBef>
+              <a:spcAft>
+                <a:spcPts val="0"/>
+              </a:spcAft>
+              <a:buNone/>
+              <a:defRPr sz="1875">
+                <a:solidFill>
+                  <a:srgbClr val="FFFFFF"/>
+                </a:solidFill>
+                <a:latin typeface="Consolas"/>
+                <a:ea typeface="Consolas"/>
+                <a:cs typeface="Consolas"/>
+              </a:defRPr>
+            </a:pPr>
+            <a:r>
+              <a:rPr sz="1875">
+                <a:solidFill>
+                  <a:srgbClr val="FFFFFF"/>
+                </a:solidFill>
+                <a:latin typeface="Consolas"/>
+                <a:ea typeface="Consolas"/>
+                <a:cs typeface="Consolas"/>
+              </a:rPr>
+              <a:t>Result:  00000010 00</a:t>
             </a:r>
           </a:p>
         </p:txBody>
@@ -16006,7 +16273,7 @@
                 <a:ea typeface="Arial"/>
                 <a:cs typeface="Arial"/>
               </a:rPr>
-              <a:t>The handout uses atoll to read the value into a long long int.</a:t>
+              <a:t>Output is printed in groups of 8 bits. The handout uses atoll to read the value into a long long int.</a:t>
             </a:r>
           </a:p>
         </p:txBody>

</xml_diff>

<commit_message>
fix: put saved bits first in the rotation walkthroughs and drop the C details slide
</commit_message>
<xml_diff>
--- a/public/presentations/cs211-recitation-01.pptx
+++ b/public/presentations/cs211-recitation-01.pptx
@@ -21,7 +21,6 @@
     <p:sldId xmlns:r="http://schemas.openxmlformats.org/officeDocument/2006/relationships" id="266" r:id="R2f1aae88ac424e63"/>
     <p:sldId xmlns:r="http://schemas.openxmlformats.org/officeDocument/2006/relationships" id="267" r:id="R397c172925d34b42"/>
     <p:sldId xmlns:r="http://schemas.openxmlformats.org/officeDocument/2006/relationships" id="268" r:id="R0ea5121eab024b1c"/>
-    <p:sldId xmlns:r="http://schemas.openxmlformats.org/officeDocument/2006/relationships" id="269" r:id="R4a2bd700edb84cd8"/>
     <p:sldId xmlns:r="http://schemas.openxmlformats.org/officeDocument/2006/relationships" id="270" r:id="Rb40defc59a9b42e1"/>
     <p:sldId xmlns:r="http://schemas.openxmlformats.org/officeDocument/2006/relationships" id="271" r:id="R5bbbf37ca1614e04"/>
   </p:sldIdLst>
@@ -733,86 +732,6 @@
             </a:pPr>
             <a:r>
               <a:t>Analogy: moving around eight seats on a carousel. One full lap is invisible in the result. Preserve the assignment’s direction convention. For nonzero W, C remainder has the sign of the dividend. Never use a negative value directly as a shift count. Handle zero before evaluating a generic expression that might shift by the storage type’s full width.</a:t>
-            </a:r>
-            <a:endParaRPr/>
-          </a:p>
-        </p:txBody>
-      </p:sp>
-      <p:sp>
-        <p:nvSpPr>
-          <p:cNvPr id="4" name="Slide Number Placeholder 3"/>
-          <p:cNvSpPr>
-            <a:spLocks xmlns:a="http://schemas.openxmlformats.org/drawingml/2006/main" noGrp="1"/>
-          </p:cNvSpPr>
-          <p:nvPr>
-            <p:ph type="sldNum" idx="5"/>
-          </p:nvPr>
-        </p:nvSpPr>
-        <p:spPr/>
-        <p:txBody>
-          <a:bodyPr xmlns:a="http://schemas.openxmlformats.org/drawingml/2006/main"/>
-          <a:lstStyle xmlns:a="http://schemas.openxmlformats.org/drawingml/2006/main"/>
-          <a:p xmlns:a="http://schemas.openxmlformats.org/drawingml/2006/main"/>
-        </p:txBody>
-      </p:sp>
-    </p:spTree>
-  </p:cSld>
-  <p:clrMapOvr>
-    <a:masterClrMapping xmlns:a="http://schemas.openxmlformats.org/drawingml/2006/main"/>
-  </p:clrMapOvr>
-</p:notes>
-</file>
-
-<file path=ppt/notesSlides/notesSlide14.xml><?xml version="1.0" encoding="utf-8"?>
-<p:notes xmlns:p="http://schemas.openxmlformats.org/presentationml/2006/main">
-  <p:cSld>
-    <p:spTree>
-      <p:nvGrpSpPr>
-        <p:cNvPr id="1" name=""/>
-        <p:cNvGrpSpPr/>
-        <p:nvPr/>
-      </p:nvGrpSpPr>
-      <p:grpSpPr>
-        <a:xfrm xmlns:a="http://schemas.openxmlformats.org/drawingml/2006/main"/>
-      </p:grpSpPr>
-      <p:sp>
-        <p:nvSpPr>
-          <p:cNvPr id="2" name="Slide Image Placeholder 1"/>
-          <p:cNvSpPr>
-            <a:spLocks xmlns:a="http://schemas.openxmlformats.org/drawingml/2006/main" noGrp="1"/>
-          </p:cNvSpPr>
-          <p:nvPr>
-            <p:ph type="sldImg" idx="0"/>
-          </p:nvPr>
-        </p:nvSpPr>
-        <p:spPr/>
-      </p:sp>
-      <p:sp>
-        <p:nvSpPr>
-          <p:cNvPr id="3" name="Notes Placeholder 2"/>
-          <p:cNvSpPr>
-            <a:spLocks xmlns:a="http://schemas.openxmlformats.org/drawingml/2006/main" noGrp="1"/>
-          </p:cNvSpPr>
-          <p:nvPr>
-            <p:ph type="body" idx="1"/>
-          </p:nvPr>
-        </p:nvSpPr>
-        <p:spPr/>
-        <p:txBody>
-          <a:bodyPr xmlns:a="http://schemas.openxmlformats.org/drawingml/2006/main"/>
-          <a:lstStyle xmlns:a="http://schemas.openxmlformats.org/drawingml/2006/main"/>
-          <a:p xmlns:a="http://schemas.openxmlformats.org/drawingml/2006/main">
-            <a:pPr marL="0" lvl="0" indent="0" algn="l">
-              <a:spcBef>
-                <a:spcPts val="0"/>
-              </a:spcBef>
-              <a:spcAft>
-                <a:spcPts val="0"/>
-              </a:spcAft>
-              <a:buNone/>
-            </a:pPr>
-            <a:r>
-              <a:t>The formal handout must define valid widths and number ranges. In common C modes on iLab, signed right shift of a negative value is implementation-defined and signed left shift can be undefined. Prefer an unsigned type and a matching literal such as 1ULL. Even an unsigned shift by the type’s width is undefined. A full-width mask needs a special case. Do not present a generic two-shift expression without discussing zero and full-width counts.</a:t>
             </a:r>
             <a:endParaRPr/>
           </a:p>
@@ -6363,7 +6282,7 @@
                 <a:ea typeface="Consolas"/>
                 <a:cs typeface="Consolas"/>
               </a:rPr>
-              <a:t>Shifted    00101100</a:t>
+              <a:t>Saved      00000011</a:t>
             </a:r>
           </a:p>
           <a:p xmlns:a="http://schemas.openxmlformats.org/drawingml/2006/main">
@@ -6396,7 +6315,7 @@
                 <a:ea typeface="Consolas"/>
                 <a:cs typeface="Consolas"/>
               </a:rPr>
-              <a:t>Saved      00000011</a:t>
+              <a:t>Shifted    00101100</a:t>
             </a:r>
           </a:p>
           <a:p xmlns:a="http://schemas.openxmlformats.org/drawingml/2006/main">
@@ -7371,7 +7290,7 @@
                 <a:ea typeface="Consolas"/>
                 <a:cs typeface="Consolas"/>
               </a:rPr>
-              <a:t>Shifted    11001100</a:t>
+              <a:t>Saved top  10</a:t>
             </a:r>
           </a:p>
           <a:p xmlns:a="http://schemas.openxmlformats.org/drawingml/2006/main">
@@ -7404,7 +7323,7 @@
                 <a:ea typeface="Consolas"/>
                 <a:cs typeface="Consolas"/>
               </a:rPr>
-              <a:t>Saved top  10</a:t>
+              <a:t>Shifted    11001100</a:t>
             </a:r>
           </a:p>
           <a:p xmlns:a="http://schemas.openxmlformats.org/drawingml/2006/main">
@@ -8611,1015 +8530,6 @@
 </p:sld>
 </file>
 
-<file path=ppt/slides/slide14.xml><?xml version="1.0" encoding="utf-8"?>
-<p:sld xmlns:p="http://schemas.openxmlformats.org/presentationml/2006/main">
-  <p:cSld>
-    <p:spTree>
-      <p:nvGrpSpPr>
-        <p:cNvPr id="1" name=""/>
-        <p:cNvGrpSpPr/>
-        <p:nvPr/>
-      </p:nvGrpSpPr>
-      <p:grpSpPr>
-        <a:xfrm xmlns:a="http://schemas.openxmlformats.org/drawingml/2006/main"/>
-      </p:grpSpPr>
-      <p:sp>
-        <p:nvSpPr>
-          <p:cNvPr id="3" name="Footer Placeholder 2">
-            <a:extLst xmlns:a="http://schemas.openxmlformats.org/drawingml/2006/main">
-              <a:ext uri="{FF2B5EF4-FFF2-40B4-BE49-F238E27FC236}">
-                <a16:creationId xmlns:a16="http://schemas.microsoft.com/office/drawing/2014/main" id="{39EA4C82-C623-0196-4A95-876ADF5DEE92}"/>
-              </a:ext>
-            </a:extLst>
-          </p:cNvPr>
-          <p:cNvSpPr>
-            <a:spLocks xmlns:a="http://schemas.openxmlformats.org/drawingml/2006/main" noGrp="1"/>
-          </p:cNvSpPr>
-          <p:nvPr>
-            <p:ph type="ftr" idx="3"/>
-          </p:nvPr>
-        </p:nvSpPr>
-        <p:spPr>
-          <a:xfrm xmlns:a="http://schemas.openxmlformats.org/drawingml/2006/main">
-            <a:off x="393700" y="6279952"/>
-            <a:ext cx="3568700" cy="241240"/>
-          </a:xfrm>
-        </p:spPr>
-        <p:txBody>
-          <a:bodyPr xmlns:a="http://schemas.openxmlformats.org/drawingml/2006/main" lIns="0" tIns="0" rIns="0" bIns="0" anchor="t">
-            <a:noAutofit/>
-          </a:bodyPr>
-          <a:lstStyle xmlns:a="http://schemas.openxmlformats.org/drawingml/2006/main"/>
-          <a:p xmlns:a="http://schemas.openxmlformats.org/drawingml/2006/main">
-            <a:pPr marL="0" indent="0">
-              <a:lnSpc>
-                <a:spcPct val="114000"/>
-              </a:lnSpc>
-              <a:spcBef>
-                <a:spcPts val="0"/>
-              </a:spcBef>
-              <a:spcAft>
-                <a:spcPts val="0"/>
-              </a:spcAft>
-              <a:buNone/>
-              <a:defRPr sz="1125">
-                <a:solidFill>
-                  <a:srgbClr val="FFFFFF"/>
-                </a:solidFill>
-                <a:latin typeface="Arial"/>
-                <a:ea typeface="Arial"/>
-                <a:cs typeface="Arial"/>
-              </a:defRPr>
-            </a:pPr>
-            <a:r>
-              <a:rPr sz="1125">
-                <a:solidFill>
-                  <a:srgbClr val="FFFFFF"/>
-                </a:solidFill>
-                <a:latin typeface="Arial"/>
-                <a:ea typeface="Arial"/>
-                <a:cs typeface="Arial"/>
-              </a:rPr>
-              <a:t>CS 211 · Recitation 01</a:t>
-            </a:r>
-          </a:p>
-        </p:txBody>
-      </p:sp>
-      <p:sp>
-        <p:nvSpPr>
-          <p:cNvPr id="532" name="Google Shape;532;p58">
-            <a:extLst xmlns:a="http://schemas.openxmlformats.org/drawingml/2006/main">
-              <a:ext uri="{FF2B5EF4-FFF2-40B4-BE49-F238E27FC236}">
-                <a16:creationId xmlns:a16="http://schemas.microsoft.com/office/drawing/2014/main" id="{1BCBE750-7048-686D-1472-52C53362D6CD}"/>
-              </a:ext>
-            </a:extLst>
-          </p:cNvPr>
-          <p:cNvSpPr>
-            <a:spLocks xmlns:a="http://schemas.openxmlformats.org/drawingml/2006/main" noGrp="1"/>
-          </p:cNvSpPr>
-          <p:nvPr>
-            <p:ph type="sldNum" idx="4"/>
-          </p:nvPr>
-        </p:nvSpPr>
-        <p:spPr>
-          <a:xfrm xmlns:a="http://schemas.openxmlformats.org/drawingml/2006/main">
-            <a:off x="11279332" y="6279294"/>
-            <a:ext cx="518968" cy="241240"/>
-          </a:xfrm>
-        </p:spPr>
-        <p:txBody>
-          <a:bodyPr xmlns:a="http://schemas.openxmlformats.org/drawingml/2006/main" spcFirstLastPara="1" vert="horz" wrap="square" lIns="0" tIns="0" rIns="0" bIns="0" anchor="t">
-            <a:noAutofit/>
-          </a:bodyPr>
-          <a:lstStyle xmlns:a="http://schemas.openxmlformats.org/drawingml/2006/main"/>
-          <a:p xmlns:a="http://schemas.openxmlformats.org/drawingml/2006/main">
-            <a:pPr marL="0" indent="0">
-              <a:lnSpc>
-                <a:spcPct val="114000"/>
-              </a:lnSpc>
-              <a:spcBef>
-                <a:spcPts val="0"/>
-              </a:spcBef>
-              <a:spcAft>
-                <a:spcPts val="0"/>
-              </a:spcAft>
-              <a:buNone/>
-              <a:defRPr sz="1125">
-                <a:solidFill>
-                  <a:srgbClr val="FFFFFF"/>
-                </a:solidFill>
-                <a:latin typeface="Arial"/>
-                <a:ea typeface="Arial"/>
-                <a:cs typeface="Arial"/>
-              </a:defRPr>
-            </a:pPr>
-            <a:r>
-              <a:rPr sz="1125">
-                <a:solidFill>
-                  <a:srgbClr val="FFFFFF"/>
-                </a:solidFill>
-                <a:latin typeface="Arial"/>
-                <a:ea typeface="Arial"/>
-                <a:cs typeface="Arial"/>
-              </a:rPr>
-              <a:t>14</a:t>
-            </a:r>
-          </a:p>
-        </p:txBody>
-      </p:sp>
-      <p:sp>
-        <p:nvSpPr>
-          <p:cNvPr id="533" name="Google Shape;533;p58">
-            <a:extLst xmlns:a="http://schemas.openxmlformats.org/drawingml/2006/main">
-              <a:ext uri="{FF2B5EF4-FFF2-40B4-BE49-F238E27FC236}">
-                <a16:creationId xmlns:a16="http://schemas.microsoft.com/office/drawing/2014/main" id="{1B5D55CD-1C17-7CD8-F26A-2DD65B067687}"/>
-              </a:ext>
-            </a:extLst>
-          </p:cNvPr>
-          <p:cNvSpPr>
-            <a:spLocks xmlns:a="http://schemas.openxmlformats.org/drawingml/2006/main" noGrp="1"/>
-          </p:cNvSpPr>
-          <p:nvPr>
-            <p:ph type="title" idx="0"/>
-          </p:nvPr>
-        </p:nvSpPr>
-        <p:spPr>
-          <a:xfrm xmlns:a="http://schemas.openxmlformats.org/drawingml/2006/main">
-            <a:off x="393700" y="344008"/>
-            <a:ext cx="11404600" cy="1047491"/>
-          </a:xfrm>
-        </p:spPr>
-        <p:txBody>
-          <a:bodyPr xmlns:a="http://schemas.openxmlformats.org/drawingml/2006/main" spcFirstLastPara="1" vert="horz" wrap="square" lIns="0" tIns="0" rIns="0" bIns="0" anchor="t">
-            <a:noAutofit/>
-          </a:bodyPr>
-          <a:lstStyle xmlns:a="http://schemas.openxmlformats.org/drawingml/2006/main"/>
-          <a:p xmlns:a="http://schemas.openxmlformats.org/drawingml/2006/main">
-            <a:pPr marL="0" indent="0">
-              <a:lnSpc>
-                <a:spcPct val="114000"/>
-              </a:lnSpc>
-              <a:spcBef>
-                <a:spcPts val="0"/>
-              </a:spcBef>
-              <a:spcAft>
-                <a:spcPts val="0"/>
-              </a:spcAft>
-              <a:buNone/>
-              <a:defRPr sz="3150">
-                <a:solidFill>
-                  <a:srgbClr val="FFFFFF"/>
-                </a:solidFill>
-                <a:latin typeface="Arial"/>
-                <a:ea typeface="Arial"/>
-                <a:cs typeface="Arial"/>
-              </a:defRPr>
-            </a:pPr>
-            <a:r>
-              <a:rPr sz="3150">
-                <a:solidFill>
-                  <a:srgbClr val="FFFFFF"/>
-                </a:solidFill>
-                <a:latin typeface="Arial"/>
-                <a:ea typeface="Arial"/>
-                <a:cs typeface="Arial"/>
-              </a:rPr>
-              <a:t>C details that matter</a:t>
-            </a:r>
-          </a:p>
-        </p:txBody>
-      </p:sp>
-      <p:sp>
-        <p:nvSpPr>
-          <p:cNvPr id="7" name="Google Shape;534;p58">
-            <a:extLst xmlns:a="http://schemas.openxmlformats.org/drawingml/2006/main">
-              <a:ext uri="{FF2B5EF4-FFF2-40B4-BE49-F238E27FC236}">
-                <a16:creationId xmlns:a16="http://schemas.microsoft.com/office/drawing/2014/main" id="{3A923FEE-B8D2-CD3A-ABBD-21770B40AA24}"/>
-              </a:ext>
-            </a:extLst>
-          </p:cNvPr>
-          <p:cNvSpPr>
-            <a:spLocks xmlns:a="http://schemas.openxmlformats.org/drawingml/2006/main" noGrp="1"/>
-          </p:cNvSpPr>
-          <p:nvPr/>
-        </p:nvSpPr>
-        <p:spPr>
-          <a:xfrm xmlns:a="http://schemas.openxmlformats.org/drawingml/2006/main">
-            <a:off x="393700" y="2031999"/>
-            <a:ext cx="5537200" cy="3534787"/>
-          </a:xfrm>
-          <a:prstGeom xmlns:a="http://schemas.openxmlformats.org/drawingml/2006/main" prst="rect">
-            <a:avLst/>
-          </a:prstGeom>
-        </p:spPr>
-        <p:txBody>
-          <a:bodyPr xmlns:a="http://schemas.openxmlformats.org/drawingml/2006/main" spcFirstLastPara="1" vert="horz" wrap="square" lIns="0" tIns="0" rIns="0" bIns="0" anchor="t">
-            <a:noAutofit/>
-          </a:bodyPr>
-          <a:lstStyle xmlns:a="http://schemas.openxmlformats.org/drawingml/2006/main">
-            <a:lvl1pPr marL="228600" indent="-228600" algn="l" defTabSz="914400">
-              <a:lnSpc>
-                <a:spcPct val="90000"/>
-              </a:lnSpc>
-              <a:spcBef>
-                <a:spcPts val="1000"/>
-              </a:spcBef>
-              <a:buFont typeface="Arial"/>
-              <a:buChar char="•"/>
-              <a:defRPr sz="2400" kern="1200">
-                <a:solidFill>
-                  <a:schemeClr val="tx1"/>
-                </a:solidFill>
-                <a:latin typeface="+mn-lt"/>
-                <a:ea typeface="+mn-lt"/>
-                <a:cs typeface="+mn-lt"/>
-              </a:defRPr>
-            </a:lvl1pPr>
-            <a:lvl2pPr marL="685800" indent="-228600" algn="l" defTabSz="914400">
-              <a:lnSpc>
-                <a:spcPct val="90000"/>
-              </a:lnSpc>
-              <a:spcBef>
-                <a:spcPts val="500"/>
-              </a:spcBef>
-              <a:buFont typeface="Arial"/>
-              <a:buChar char="•"/>
-              <a:defRPr sz="2000" kern="1200">
-                <a:solidFill>
-                  <a:schemeClr val="tx1"/>
-                </a:solidFill>
-                <a:latin typeface="+mn-lt"/>
-                <a:ea typeface="+mn-lt"/>
-                <a:cs typeface="+mn-lt"/>
-              </a:defRPr>
-            </a:lvl2pPr>
-            <a:lvl3pPr marL="1143000" indent="-228600" algn="l" defTabSz="914400">
-              <a:lnSpc>
-                <a:spcPct val="90000"/>
-              </a:lnSpc>
-              <a:spcBef>
-                <a:spcPts val="500"/>
-              </a:spcBef>
-              <a:buFont typeface="Arial"/>
-              <a:buChar char="•"/>
-              <a:defRPr sz="1800" kern="1200">
-                <a:solidFill>
-                  <a:schemeClr val="tx1"/>
-                </a:solidFill>
-                <a:latin typeface="+mn-lt"/>
-                <a:ea typeface="+mn-lt"/>
-                <a:cs typeface="+mn-lt"/>
-              </a:defRPr>
-            </a:lvl3pPr>
-            <a:lvl4pPr marL="1600200" indent="-228600" algn="l" defTabSz="914400">
-              <a:lnSpc>
-                <a:spcPct val="90000"/>
-              </a:lnSpc>
-              <a:spcBef>
-                <a:spcPts val="500"/>
-              </a:spcBef>
-              <a:buFont typeface="Arial"/>
-              <a:buChar char="•"/>
-              <a:defRPr sz="1800" kern="1200">
-                <a:solidFill>
-                  <a:schemeClr val="tx1"/>
-                </a:solidFill>
-                <a:latin typeface="+mn-lt"/>
-                <a:ea typeface="+mn-lt"/>
-                <a:cs typeface="+mn-lt"/>
-              </a:defRPr>
-            </a:lvl4pPr>
-            <a:lvl5pPr marL="2057400" indent="-228600" algn="l" defTabSz="914400">
-              <a:lnSpc>
-                <a:spcPct val="90000"/>
-              </a:lnSpc>
-              <a:spcBef>
-                <a:spcPts val="500"/>
-              </a:spcBef>
-              <a:buFont typeface="Arial"/>
-              <a:buChar char="•"/>
-              <a:defRPr sz="1800" kern="1200">
-                <a:solidFill>
-                  <a:schemeClr val="tx1"/>
-                </a:solidFill>
-                <a:latin typeface="+mn-lt"/>
-                <a:ea typeface="+mn-lt"/>
-                <a:cs typeface="+mn-lt"/>
-              </a:defRPr>
-            </a:lvl5pPr>
-            <a:lvl6pPr marL="2514600" indent="-228600" algn="l" defTabSz="914400">
-              <a:lnSpc>
-                <a:spcPct val="90000"/>
-              </a:lnSpc>
-              <a:spcBef>
-                <a:spcPts val="500"/>
-              </a:spcBef>
-              <a:buFont typeface="Arial"/>
-              <a:buChar char="•"/>
-              <a:defRPr sz="1800" kern="1200">
-                <a:solidFill>
-                  <a:schemeClr val="tx1"/>
-                </a:solidFill>
-                <a:latin typeface="+mn-lt"/>
-                <a:ea typeface="+mn-lt"/>
-                <a:cs typeface="+mn-lt"/>
-              </a:defRPr>
-            </a:lvl6pPr>
-            <a:lvl7pPr marL="2971800" indent="-228600" algn="l" defTabSz="914400">
-              <a:lnSpc>
-                <a:spcPct val="90000"/>
-              </a:lnSpc>
-              <a:spcBef>
-                <a:spcPts val="500"/>
-              </a:spcBef>
-              <a:buFont typeface="Arial"/>
-              <a:buChar char="•"/>
-              <a:defRPr sz="1800" kern="1200">
-                <a:solidFill>
-                  <a:schemeClr val="tx1"/>
-                </a:solidFill>
-                <a:latin typeface="+mn-lt"/>
-                <a:ea typeface="+mn-lt"/>
-                <a:cs typeface="+mn-lt"/>
-              </a:defRPr>
-            </a:lvl7pPr>
-            <a:lvl8pPr marL="3429000" indent="-228600" algn="l" defTabSz="914400">
-              <a:lnSpc>
-                <a:spcPct val="90000"/>
-              </a:lnSpc>
-              <a:spcBef>
-                <a:spcPts val="500"/>
-              </a:spcBef>
-              <a:buFont typeface="Arial"/>
-              <a:buChar char="•"/>
-              <a:defRPr sz="1800" kern="1200">
-                <a:solidFill>
-                  <a:schemeClr val="tx1"/>
-                </a:solidFill>
-                <a:latin typeface="+mn-lt"/>
-                <a:ea typeface="+mn-lt"/>
-                <a:cs typeface="+mn-lt"/>
-              </a:defRPr>
-            </a:lvl8pPr>
-            <a:lvl9pPr marL="3886200" indent="-228600" algn="l" defTabSz="914400">
-              <a:lnSpc>
-                <a:spcPct val="90000"/>
-              </a:lnSpc>
-              <a:spcBef>
-                <a:spcPts val="500"/>
-              </a:spcBef>
-              <a:buFont typeface="Arial"/>
-              <a:buChar char="•"/>
-              <a:defRPr sz="1800" kern="1200">
-                <a:solidFill>
-                  <a:schemeClr val="tx1"/>
-                </a:solidFill>
-                <a:latin typeface="+mn-lt"/>
-                <a:ea typeface="+mn-lt"/>
-                <a:cs typeface="+mn-lt"/>
-              </a:defRPr>
-            </a:lvl9pPr>
-          </a:lstStyle>
-          <a:p xmlns:a="http://schemas.openxmlformats.org/drawingml/2006/main">
-            <a:pPr marL="0" indent="0">
-              <a:lnSpc>
-                <a:spcPct val="114000"/>
-              </a:lnSpc>
-              <a:spcBef>
-                <a:spcPts val="0"/>
-              </a:spcBef>
-              <a:spcAft>
-                <a:spcPts val="0"/>
-              </a:spcAft>
-              <a:buNone/>
-              <a:defRPr sz="1950">
-                <a:solidFill>
-                  <a:srgbClr val="FFFFFF"/>
-                </a:solidFill>
-                <a:latin typeface="Arial"/>
-                <a:ea typeface="Arial"/>
-                <a:cs typeface="Arial"/>
-              </a:defRPr>
-            </a:pPr>
-            <a:r>
-              <a:rPr sz="1950">
-                <a:solidFill>
-                  <a:srgbClr val="FFFFFF"/>
-                </a:solidFill>
-                <a:latin typeface="Arial"/>
-                <a:ea typeface="Arial"/>
-                <a:cs typeface="Arial"/>
-              </a:rPr>
-              <a:t>Use unsigned values for bit manipulation.</a:t>
-            </a:r>
-          </a:p>
-          <a:p xmlns:a="http://schemas.openxmlformats.org/drawingml/2006/main">
-            <a:pPr marL="0" indent="0">
-              <a:lnSpc>
-                <a:spcPct val="114000"/>
-              </a:lnSpc>
-              <a:spcBef>
-                <a:spcPts val="0"/>
-              </a:spcBef>
-              <a:spcAft>
-                <a:spcPts val="0"/>
-              </a:spcAft>
-              <a:buNone/>
-            </a:pPr>
-            <a:r>
-              <a:t/>
-            </a:r>
-          </a:p>
-          <a:p xmlns:a="http://schemas.openxmlformats.org/drawingml/2006/main">
-            <a:pPr marL="0" indent="0">
-              <a:lnSpc>
-                <a:spcPct val="114000"/>
-              </a:lnSpc>
-              <a:spcBef>
-                <a:spcPts val="0"/>
-              </a:spcBef>
-              <a:spcAft>
-                <a:spcPts val="0"/>
-              </a:spcAft>
-              <a:buNone/>
-              <a:defRPr sz="1950">
-                <a:solidFill>
-                  <a:srgbClr val="FFFFFF"/>
-                </a:solidFill>
-                <a:latin typeface="Arial"/>
-                <a:ea typeface="Arial"/>
-                <a:cs typeface="Arial"/>
-              </a:defRPr>
-            </a:pPr>
-            <a:r>
-              <a:rPr sz="1950">
-                <a:solidFill>
-                  <a:srgbClr val="FFFFFF"/>
-                </a:solidFill>
-                <a:latin typeface="Arial"/>
-                <a:ea typeface="Arial"/>
-                <a:cs typeface="Arial"/>
-              </a:rPr>
-              <a:t>The selected bit width and the storage type’s width can differ.</a:t>
-            </a:r>
-          </a:p>
-          <a:p xmlns:a="http://schemas.openxmlformats.org/drawingml/2006/main">
-            <a:pPr marL="0" indent="0">
-              <a:lnSpc>
-                <a:spcPct val="114000"/>
-              </a:lnSpc>
-              <a:spcBef>
-                <a:spcPts val="0"/>
-              </a:spcBef>
-              <a:spcAft>
-                <a:spcPts val="0"/>
-              </a:spcAft>
-              <a:buNone/>
-            </a:pPr>
-            <a:r>
-              <a:t/>
-            </a:r>
-          </a:p>
-          <a:p xmlns:a="http://schemas.openxmlformats.org/drawingml/2006/main">
-            <a:pPr marL="0" indent="0">
-              <a:lnSpc>
-                <a:spcPct val="114000"/>
-              </a:lnSpc>
-              <a:spcBef>
-                <a:spcPts val="0"/>
-              </a:spcBef>
-              <a:spcAft>
-                <a:spcPts val="0"/>
-              </a:spcAft>
-              <a:buNone/>
-              <a:defRPr sz="1950">
-                <a:solidFill>
-                  <a:srgbClr val="FFFFFF"/>
-                </a:solidFill>
-                <a:latin typeface="Arial"/>
-                <a:ea typeface="Arial"/>
-                <a:cs typeface="Arial"/>
-              </a:defRPr>
-            </a:pPr>
-            <a:r>
-              <a:rPr sz="1950">
-                <a:solidFill>
-                  <a:srgbClr val="FFFFFF"/>
-                </a:solidFill>
-                <a:latin typeface="Arial"/>
-                <a:ea typeface="Arial"/>
-                <a:cs typeface="Arial"/>
-              </a:rPr>
-              <a:t>A shift count must be nonnegative and smaller than the promoted left operand’s width.</a:t>
-            </a:r>
-          </a:p>
-        </p:txBody>
-      </p:sp>
-      <p:sp>
-        <p:nvSpPr>
-          <p:cNvPr id="8" name="Content Placeholder 3">
-            <a:extLst xmlns:a="http://schemas.openxmlformats.org/drawingml/2006/main">
-              <a:ext uri="{FF2B5EF4-FFF2-40B4-BE49-F238E27FC236}">
-                <a16:creationId xmlns:a16="http://schemas.microsoft.com/office/drawing/2014/main" id="{2EE8F343-A95F-2AAA-FE9E-A6C31E298DF7}"/>
-              </a:ext>
-            </a:extLst>
-          </p:cNvPr>
-          <p:cNvSpPr>
-            <a:spLocks xmlns:a="http://schemas.openxmlformats.org/drawingml/2006/main" noGrp="1"/>
-          </p:cNvSpPr>
-          <p:nvPr/>
-        </p:nvSpPr>
-        <p:spPr>
-          <a:xfrm xmlns:a="http://schemas.openxmlformats.org/drawingml/2006/main">
-            <a:off x="6256618" y="2031999"/>
-            <a:ext cx="5537200" cy="3534787"/>
-          </a:xfrm>
-          <a:prstGeom xmlns:a="http://schemas.openxmlformats.org/drawingml/2006/main" prst="rect">
-            <a:avLst/>
-          </a:prstGeom>
-        </p:spPr>
-        <p:txBody>
-          <a:bodyPr xmlns:a="http://schemas.openxmlformats.org/drawingml/2006/main" lIns="0" tIns="0" rIns="0" bIns="0" anchor="t">
-            <a:noAutofit/>
-          </a:bodyPr>
-          <a:lstStyle xmlns:a="http://schemas.openxmlformats.org/drawingml/2006/main">
-            <a:lvl1pPr marL="228600" indent="-228600" algn="l" defTabSz="914400">
-              <a:lnSpc>
-                <a:spcPct val="90000"/>
-              </a:lnSpc>
-              <a:spcBef>
-                <a:spcPts val="1000"/>
-              </a:spcBef>
-              <a:buFont typeface="Arial"/>
-              <a:buChar char="•"/>
-              <a:defRPr sz="2400" kern="1200">
-                <a:solidFill>
-                  <a:schemeClr val="tx1"/>
-                </a:solidFill>
-                <a:latin typeface="+mn-lt"/>
-                <a:ea typeface="+mn-lt"/>
-                <a:cs typeface="+mn-lt"/>
-              </a:defRPr>
-            </a:lvl1pPr>
-            <a:lvl2pPr marL="685800" indent="-228600" algn="l" defTabSz="914400">
-              <a:lnSpc>
-                <a:spcPct val="90000"/>
-              </a:lnSpc>
-              <a:spcBef>
-                <a:spcPts val="500"/>
-              </a:spcBef>
-              <a:buFont typeface="Arial"/>
-              <a:buChar char="•"/>
-              <a:defRPr sz="2000" kern="1200">
-                <a:solidFill>
-                  <a:schemeClr val="tx1"/>
-                </a:solidFill>
-                <a:latin typeface="+mn-lt"/>
-                <a:ea typeface="+mn-lt"/>
-                <a:cs typeface="+mn-lt"/>
-              </a:defRPr>
-            </a:lvl2pPr>
-            <a:lvl3pPr marL="1143000" indent="-228600" algn="l" defTabSz="914400">
-              <a:lnSpc>
-                <a:spcPct val="90000"/>
-              </a:lnSpc>
-              <a:spcBef>
-                <a:spcPts val="500"/>
-              </a:spcBef>
-              <a:buFont typeface="Arial"/>
-              <a:buChar char="•"/>
-              <a:defRPr sz="1800" kern="1200">
-                <a:solidFill>
-                  <a:schemeClr val="tx1"/>
-                </a:solidFill>
-                <a:latin typeface="+mn-lt"/>
-                <a:ea typeface="+mn-lt"/>
-                <a:cs typeface="+mn-lt"/>
-              </a:defRPr>
-            </a:lvl3pPr>
-            <a:lvl4pPr marL="1600200" indent="-228600" algn="l" defTabSz="914400">
-              <a:lnSpc>
-                <a:spcPct val="90000"/>
-              </a:lnSpc>
-              <a:spcBef>
-                <a:spcPts val="500"/>
-              </a:spcBef>
-              <a:buFont typeface="Arial"/>
-              <a:buChar char="•"/>
-              <a:defRPr sz="1800" kern="1200">
-                <a:solidFill>
-                  <a:schemeClr val="tx1"/>
-                </a:solidFill>
-                <a:latin typeface="+mn-lt"/>
-                <a:ea typeface="+mn-lt"/>
-                <a:cs typeface="+mn-lt"/>
-              </a:defRPr>
-            </a:lvl4pPr>
-            <a:lvl5pPr marL="2057400" indent="-228600" algn="l" defTabSz="914400">
-              <a:lnSpc>
-                <a:spcPct val="90000"/>
-              </a:lnSpc>
-              <a:spcBef>
-                <a:spcPts val="500"/>
-              </a:spcBef>
-              <a:buFont typeface="Arial"/>
-              <a:buChar char="•"/>
-              <a:defRPr sz="1800" kern="1200">
-                <a:solidFill>
-                  <a:schemeClr val="tx1"/>
-                </a:solidFill>
-                <a:latin typeface="+mn-lt"/>
-                <a:ea typeface="+mn-lt"/>
-                <a:cs typeface="+mn-lt"/>
-              </a:defRPr>
-            </a:lvl5pPr>
-            <a:lvl6pPr marL="2514600" indent="-228600" algn="l" defTabSz="914400">
-              <a:lnSpc>
-                <a:spcPct val="90000"/>
-              </a:lnSpc>
-              <a:spcBef>
-                <a:spcPts val="500"/>
-              </a:spcBef>
-              <a:buFont typeface="Arial"/>
-              <a:buChar char="•"/>
-              <a:defRPr sz="1800" kern="1200">
-                <a:solidFill>
-                  <a:schemeClr val="tx1"/>
-                </a:solidFill>
-                <a:latin typeface="+mn-lt"/>
-                <a:ea typeface="+mn-lt"/>
-                <a:cs typeface="+mn-lt"/>
-              </a:defRPr>
-            </a:lvl6pPr>
-            <a:lvl7pPr marL="2971800" indent="-228600" algn="l" defTabSz="914400">
-              <a:lnSpc>
-                <a:spcPct val="90000"/>
-              </a:lnSpc>
-              <a:spcBef>
-                <a:spcPts val="500"/>
-              </a:spcBef>
-              <a:buFont typeface="Arial"/>
-              <a:buChar char="•"/>
-              <a:defRPr sz="1800" kern="1200">
-                <a:solidFill>
-                  <a:schemeClr val="tx1"/>
-                </a:solidFill>
-                <a:latin typeface="+mn-lt"/>
-                <a:ea typeface="+mn-lt"/>
-                <a:cs typeface="+mn-lt"/>
-              </a:defRPr>
-            </a:lvl7pPr>
-            <a:lvl8pPr marL="3429000" indent="-228600" algn="l" defTabSz="914400">
-              <a:lnSpc>
-                <a:spcPct val="90000"/>
-              </a:lnSpc>
-              <a:spcBef>
-                <a:spcPts val="500"/>
-              </a:spcBef>
-              <a:buFont typeface="Arial"/>
-              <a:buChar char="•"/>
-              <a:defRPr sz="1800" kern="1200">
-                <a:solidFill>
-                  <a:schemeClr val="tx1"/>
-                </a:solidFill>
-                <a:latin typeface="+mn-lt"/>
-                <a:ea typeface="+mn-lt"/>
-                <a:cs typeface="+mn-lt"/>
-              </a:defRPr>
-            </a:lvl8pPr>
-            <a:lvl9pPr marL="3886200" indent="-228600" algn="l" defTabSz="914400">
-              <a:lnSpc>
-                <a:spcPct val="90000"/>
-              </a:lnSpc>
-              <a:spcBef>
-                <a:spcPts val="500"/>
-              </a:spcBef>
-              <a:buFont typeface="Arial"/>
-              <a:buChar char="•"/>
-              <a:defRPr sz="1800" kern="1200">
-                <a:solidFill>
-                  <a:schemeClr val="tx1"/>
-                </a:solidFill>
-                <a:latin typeface="+mn-lt"/>
-                <a:ea typeface="+mn-lt"/>
-                <a:cs typeface="+mn-lt"/>
-              </a:defRPr>
-            </a:lvl9pPr>
-          </a:lstStyle>
-          <a:p xmlns:a="http://schemas.openxmlformats.org/drawingml/2006/main">
-            <a:pPr marL="0" indent="0">
-              <a:lnSpc>
-                <a:spcPct val="114000"/>
-              </a:lnSpc>
-              <a:spcBef>
-                <a:spcPts val="0"/>
-              </a:spcBef>
-              <a:spcAft>
-                <a:spcPts val="0"/>
-              </a:spcAft>
-              <a:buNone/>
-              <a:defRPr sz="1875">
-                <a:solidFill>
-                  <a:srgbClr val="FFFFFF"/>
-                </a:solidFill>
-                <a:latin typeface="Consolas"/>
-                <a:ea typeface="Consolas"/>
-                <a:cs typeface="Consolas"/>
-              </a:defRPr>
-            </a:pPr>
-            <a:r>
-              <a:rPr sz="1875">
-                <a:solidFill>
-                  <a:srgbClr val="FFFFFF"/>
-                </a:solidFill>
-                <a:latin typeface="Consolas"/>
-                <a:ea typeface="Consolas"/>
-                <a:cs typeface="Consolas"/>
-              </a:rPr>
-              <a:t>Check before shifting</a:t>
-            </a:r>
-          </a:p>
-          <a:p xmlns:a="http://schemas.openxmlformats.org/drawingml/2006/main">
-            <a:pPr marL="0" indent="0">
-              <a:lnSpc>
-                <a:spcPct val="114000"/>
-              </a:lnSpc>
-              <a:spcBef>
-                <a:spcPts val="0"/>
-              </a:spcBef>
-              <a:spcAft>
-                <a:spcPts val="0"/>
-              </a:spcAft>
-              <a:buNone/>
-            </a:pPr>
-            <a:r>
-              <a:t/>
-            </a:r>
-          </a:p>
-          <a:p xmlns:a="http://schemas.openxmlformats.org/drawingml/2006/main">
-            <a:pPr marL="0" indent="0">
-              <a:lnSpc>
-                <a:spcPct val="114000"/>
-              </a:lnSpc>
-              <a:spcBef>
-                <a:spcPts val="0"/>
-              </a:spcBef>
-              <a:spcAft>
-                <a:spcPts val="0"/>
-              </a:spcAft>
-              <a:buNone/>
-              <a:defRPr sz="1875">
-                <a:solidFill>
-                  <a:srgbClr val="FFFFFF"/>
-                </a:solidFill>
-                <a:latin typeface="Consolas"/>
-                <a:ea typeface="Consolas"/>
-                <a:cs typeface="Consolas"/>
-              </a:defRPr>
-            </a:pPr>
-            <a:r>
-              <a:rPr sz="1875">
-                <a:solidFill>
-                  <a:srgbClr val="FFFFFF"/>
-                </a:solidFill>
-                <a:latin typeface="Consolas"/>
-                <a:ea typeface="Consolas"/>
-                <a:cs typeface="Consolas"/>
-              </a:rPr>
-              <a:t>Is W valid?</a:t>
-            </a:r>
-          </a:p>
-          <a:p xmlns:a="http://schemas.openxmlformats.org/drawingml/2006/main">
-            <a:pPr marL="0" indent="0">
-              <a:lnSpc>
-                <a:spcPct val="114000"/>
-              </a:lnSpc>
-              <a:spcBef>
-                <a:spcPts val="0"/>
-              </a:spcBef>
-              <a:spcAft>
-                <a:spcPts val="0"/>
-              </a:spcAft>
-              <a:buNone/>
-              <a:defRPr sz="1875">
-                <a:solidFill>
-                  <a:srgbClr val="FFFFFF"/>
-                </a:solidFill>
-                <a:latin typeface="Consolas"/>
-                <a:ea typeface="Consolas"/>
-                <a:cs typeface="Consolas"/>
-              </a:defRPr>
-            </a:pPr>
-            <a:r>
-              <a:rPr sz="1875">
-                <a:solidFill>
-                  <a:srgbClr val="FFFFFF"/>
-                </a:solidFill>
-                <a:latin typeface="Consolas"/>
-                <a:ea typeface="Consolas"/>
-                <a:cs typeface="Consolas"/>
-              </a:rPr>
-              <a:t>Is the count reduced?</a:t>
-            </a:r>
-          </a:p>
-          <a:p xmlns:a="http://schemas.openxmlformats.org/drawingml/2006/main">
-            <a:pPr marL="0" indent="0">
-              <a:lnSpc>
-                <a:spcPct val="114000"/>
-              </a:lnSpc>
-              <a:spcBef>
-                <a:spcPts val="0"/>
-              </a:spcBef>
-              <a:spcAft>
-                <a:spcPts val="0"/>
-              </a:spcAft>
-              <a:buNone/>
-              <a:defRPr sz="1875">
-                <a:solidFill>
-                  <a:srgbClr val="FFFFFF"/>
-                </a:solidFill>
-                <a:latin typeface="Consolas"/>
-                <a:ea typeface="Consolas"/>
-                <a:cs typeface="Consolas"/>
-              </a:defRPr>
-            </a:pPr>
-            <a:r>
-              <a:rPr sz="1875">
-                <a:solidFill>
-                  <a:srgbClr val="FFFFFF"/>
-                </a:solidFill>
-                <a:latin typeface="Consolas"/>
-                <a:ea typeface="Consolas"/>
-                <a:cs typeface="Consolas"/>
-              </a:rPr>
-              <a:t>Is the count zero?</a:t>
-            </a:r>
-          </a:p>
-          <a:p xmlns:a="http://schemas.openxmlformats.org/drawingml/2006/main">
-            <a:pPr marL="0" indent="0">
-              <a:lnSpc>
-                <a:spcPct val="114000"/>
-              </a:lnSpc>
-              <a:spcBef>
-                <a:spcPts val="0"/>
-              </a:spcBef>
-              <a:spcAft>
-                <a:spcPts val="0"/>
-              </a:spcAft>
-              <a:buNone/>
-              <a:defRPr sz="1875">
-                <a:solidFill>
-                  <a:srgbClr val="FFFFFF"/>
-                </a:solidFill>
-                <a:latin typeface="Consolas"/>
-                <a:ea typeface="Consolas"/>
-                <a:cs typeface="Consolas"/>
-              </a:defRPr>
-            </a:pPr>
-            <a:r>
-              <a:rPr sz="1875">
-                <a:solidFill>
-                  <a:srgbClr val="FFFFFF"/>
-                </a:solidFill>
-                <a:latin typeface="Consolas"/>
-                <a:ea typeface="Consolas"/>
-                <a:cs typeface="Consolas"/>
-              </a:rPr>
-              <a:t>Is the mask wide enough?</a:t>
-            </a:r>
-          </a:p>
-          <a:p xmlns:a="http://schemas.openxmlformats.org/drawingml/2006/main">
-            <a:pPr marL="0" indent="0">
-              <a:lnSpc>
-                <a:spcPct val="114000"/>
-              </a:lnSpc>
-              <a:spcBef>
-                <a:spcPts val="0"/>
-              </a:spcBef>
-              <a:spcAft>
-                <a:spcPts val="0"/>
-              </a:spcAft>
-              <a:buNone/>
-              <a:defRPr sz="1875">
-                <a:solidFill>
-                  <a:srgbClr val="FFFFFF"/>
-                </a:solidFill>
-                <a:latin typeface="Consolas"/>
-                <a:ea typeface="Consolas"/>
-                <a:cs typeface="Consolas"/>
-              </a:defRPr>
-            </a:pPr>
-            <a:r>
-              <a:rPr sz="1875">
-                <a:solidFill>
-                  <a:srgbClr val="FFFFFF"/>
-                </a:solidFill>
-                <a:latin typeface="Consolas"/>
-                <a:ea typeface="Consolas"/>
-                <a:cs typeface="Consolas"/>
-              </a:rPr>
-              <a:t>Are only W result bits kept?</a:t>
-            </a:r>
-          </a:p>
-        </p:txBody>
-      </p:sp>
-      <p:sp>
-        <p:nvSpPr>
-          <p:cNvPr id="534" name="Takeaway">
-            <a:extLst xmlns:a="http://schemas.openxmlformats.org/drawingml/2006/main">
-              <a:ext uri="{FF2B5EF4-FFF2-40B4-BE49-F238E27FC236}">
-                <a16:creationId xmlns:a16="http://schemas.microsoft.com/office/drawing/2014/main" id="{9096AD39-706B-410B-B168-CD9C490402DF}"/>
-              </a:ext>
-            </a:extLst>
-          </p:cNvPr>
-          <p:cNvSpPr>
-            <a:spLocks xmlns:a="http://schemas.openxmlformats.org/drawingml/2006/main" noGrp="1"/>
-          </p:cNvSpPr>
-          <p:nvPr/>
-        </p:nvSpPr>
-        <p:spPr>
-          <a:xfrm xmlns:a="http://schemas.openxmlformats.org/drawingml/2006/main">
-            <a:off x="393668" y="5734050"/>
-            <a:ext cx="11404283" cy="428625"/>
-          </a:xfrm>
-          <a:prstGeom xmlns:a="http://schemas.openxmlformats.org/drawingml/2006/main" prst="rect">
-            <a:avLst/>
-          </a:prstGeom>
-          <a:noFill xmlns:a="http://schemas.openxmlformats.org/drawingml/2006/main"/>
-          <a:ln xmlns:a="http://schemas.openxmlformats.org/drawingml/2006/main" w="0">
-            <a:noFill/>
-          </a:ln>
-        </p:spPr>
-        <p:txBody>
-          <a:bodyPr xmlns:a="http://schemas.openxmlformats.org/drawingml/2006/main" lIns="0" tIns="0" rIns="0" bIns="0" anchor="t">
-            <a:noAutofit/>
-          </a:bodyPr>
-          <a:lstStyle xmlns:a="http://schemas.openxmlformats.org/drawingml/2006/main"/>
-          <a:p xmlns:a="http://schemas.openxmlformats.org/drawingml/2006/main">
-            <a:pPr marL="0" indent="0">
-              <a:lnSpc>
-                <a:spcPct val="114000"/>
-              </a:lnSpc>
-              <a:spcBef>
-                <a:spcPts val="0"/>
-              </a:spcBef>
-              <a:spcAft>
-                <a:spcPts val="0"/>
-              </a:spcAft>
-              <a:buNone/>
-              <a:defRPr sz="1575">
-                <a:solidFill>
-                  <a:srgbClr val="CCCCCC"/>
-                </a:solidFill>
-                <a:latin typeface="Arial"/>
-                <a:ea typeface="Arial"/>
-                <a:cs typeface="Arial"/>
-              </a:defRPr>
-            </a:pPr>
-            <a:r>
-              <a:rPr sz="1575">
-                <a:solidFill>
-                  <a:srgbClr val="CCCCCC"/>
-                </a:solidFill>
-                <a:latin typeface="Arial"/>
-                <a:ea typeface="Arial"/>
-                <a:cs typeface="Arial"/>
-              </a:rPr>
-              <a:t>A 32-bit mask cannot describe the top of a 40-bit value.</a:t>
-            </a:r>
-          </a:p>
-        </p:txBody>
-      </p:sp>
-    </p:spTree>
-    <p:extLst>
-      <p:ext uri="{BB962C8B-B14F-4D97-AF65-F5344CB8AC3E}">
-        <p14:creationId xmlns:p14="http://schemas.microsoft.com/office/powerpoint/2010/main" val="3667182145"/>
-      </p:ext>
-    </p:extLst>
-  </p:cSld>
-</p:sld>
-</file>
-
 <file path=ppt/slides/slide15.xml><?xml version="1.0" encoding="utf-8"?>
 <p:sld xmlns:p="http://schemas.openxmlformats.org/presentationml/2006/main">
   <p:cSld>
@@ -9751,7 +8661,7 @@
                 <a:ea typeface="Arial"/>
                 <a:cs typeface="Arial"/>
               </a:rPr>
-              <a:t>15</a:t>
+              <a:t>14</a:t>
             </a:r>
           </a:p>
         </p:txBody>
@@ -10189,7 +9099,7 @@
                 <a:ea typeface="Arial"/>
                 <a:cs typeface="Arial"/>
               </a:rPr>
-              <a:t>3. Rotate it right by 11.</a:t>
+              <a:t>3. Rotate 10010110 right by 11.</a:t>
             </a:r>
           </a:p>
         </p:txBody>
@@ -10777,7 +9687,7 @@
                 <a:ea typeface="Arial"/>
                 <a:cs typeface="Arial"/>
               </a:rPr>
-              <a:t>16</a:t>
+              <a:t>15</a:t>
             </a:r>
           </a:p>
         </p:txBody>

</xml_diff>